<commit_message>
Fiches outils: Pilot Mill, Taper Mill et autres (en cours)
Co-Authored-By: Claude Sonnet 5.5 <noreply@anthropic.com>
Claude-Session: https://claude.ai/code/session_01XPwnZBmWUGhvYebrP3X3Z2
</commit_message>
<xml_diff>
--- a/fiches_outils/Fiche_technique_PipeCutter.pptx
+++ b/fiches_outils/Fiche_technique_PipeCutter.pptx
@@ -4483,7 +4483,7 @@
         <p:spPr>
           <a:xfrm>
             <a:off x="762000" y="6223000"/>
-            <a:ext cx="2997200" cy="941845"/>
+            <a:ext cx="3175000" cy="997717"/>
           </a:xfrm>
           <a:prstGeom prst="rect">
             <a:avLst/>
@@ -4498,7 +4498,7 @@
         </p:nvSpPr>
         <p:spPr>
           <a:xfrm>
-            <a:off x="711200" y="7188200"/>
+            <a:off x="711200" y="7289800"/>
             <a:ext cx="3048000" cy="177800"/>
           </a:xfrm>
           <a:prstGeom prst="rect">
@@ -4540,7 +4540,7 @@
         </p:nvSpPr>
         <p:spPr>
           <a:xfrm>
-            <a:off x="711200" y="7391400"/>
+            <a:off x="711200" y="7493000"/>
             <a:ext cx="3048000" cy="127000"/>
           </a:xfrm>
           <a:prstGeom prst="rect">
@@ -5813,7 +5813,7 @@
         </p:nvSpPr>
         <p:spPr>
           <a:xfrm>
-            <a:off x="4089400" y="9649460"/>
+            <a:off x="4089400" y="9189720"/>
             <a:ext cx="2755900" cy="177800"/>
           </a:xfrm>
           <a:prstGeom prst="rect">
@@ -5855,7 +5855,7 @@
         </p:nvSpPr>
         <p:spPr>
           <a:xfrm>
-            <a:off x="4089400" y="9839960"/>
+            <a:off x="4089400" y="9380220"/>
             <a:ext cx="2755900" cy="508000"/>
           </a:xfrm>
           <a:prstGeom prst="rect">

</xml_diff>